<commit_message>
test(viewer): fix PowerPoint fixture geometry
</commit_message>
<xml_diff>
--- a/tests/fixtures/document-viewer/pptx/basic.pptx
+++ b/tests/fixtures/document-viewer/pptx/basic.pptx
@@ -63,7 +63,12 @@
           <p:cNvSpPr/>
           <p:nvPr/>
         </p:nvSpPr>
-        <p:spPr/>
+        <p:spPr>
+          <a:xfrm>
+            <a:off x="914400" y="548640"/>
+            <a:ext cx="10058400" cy="1097280"/>
+          </a:xfrm>
+        </p:spPr>
         <p:txBody>
           <a:bodyPr/>
           <a:lstStyle/>
@@ -81,7 +86,10 @@
           <p:cNvGraphicFramePr/>
           <p:nvPr/>
         </p:nvGraphicFramePr>
-        <p:xfrm/>
+        <p:xfrm>
+          <a:off x="914400" y="2194560"/>
+          <a:ext cx="4572000" cy="1828800"/>
+        </p:xfrm>
         <a:graphic>
           <a:graphicData uri="http://schemas.openxmlformats.org/drawingml/2006/table">
             <a:tbl>
@@ -154,7 +162,12 @@
           <p:cNvSpPr/>
           <p:nvPr/>
         </p:nvSpPr>
-        <p:spPr/>
+        <p:spPr>
+          <a:xfrm>
+            <a:off x="914400" y="4572000"/>
+            <a:ext cx="6400800" cy="457200"/>
+          </a:xfrm>
+        </p:spPr>
         <p:txBody>
           <a:bodyPr/>
           <a:lstStyle/>
@@ -171,7 +184,12 @@
           <p:cNvSpPr/>
           <p:nvPr/>
         </p:nvSpPr>
-        <p:spPr/>
+        <p:spPr>
+          <a:xfrm>
+            <a:off x="8686800" y="5486400"/>
+            <a:ext cx="1828800" cy="457200"/>
+          </a:xfrm>
+        </p:spPr>
         <p:txBody>
           <a:bodyPr/>
           <a:lstStyle/>
@@ -206,7 +224,12 @@
           <p:cNvSpPr/>
           <p:nvPr/>
         </p:nvSpPr>
-        <p:spPr/>
+        <p:spPr>
+          <a:xfrm>
+            <a:off x="914400" y="548640"/>
+            <a:ext cx="10058400" cy="1097280"/>
+          </a:xfrm>
+        </p:spPr>
         <p:txBody>
           <a:bodyPr/>
           <a:lstStyle/>

</xml_diff>